<commit_message>
Rebrand: reader is now Comicaa, editor is Comicaa ACBF Panel Editor
Renamed across the manifest, page titles, in-app UI text, README, and
architecture doc. Bumped the service worker cache since index.html,
editor.html, and manifest.json all changed.

The demo deck's title slide now leads with the Comicaa wordmark and an
"ACBF Panel Editor" tag line underneath it. Its 3 product screenshots
showed the old name baked into the app's own header bar, so they were
recaptured against the live rebranded app (loaded via a disposable
single-page test archive), and the PDF/PPTX exports rebuilt from the
updated deck.

Co-Authored-By: Claude Sonnet 5 <noreply@anthropic.com>
</commit_message>
<xml_diff>
--- a/demo/ACBF_Panel_Editor_Demo.pptx
+++ b/demo/ACBF_Panel_Editor_Demo.pptx
@@ -3295,7 +3295,7 @@
         <p:spPr>
           <a:xfrm>
             <a:off x="685800" y="960120"/>
-            <a:ext cx="6400800" cy="1737360"/>
+            <a:ext cx="6400800" cy="914400"/>
           </a:xfrm>
           <a:prstGeom prst="rect">
             <a:avLst/>
@@ -3314,36 +3314,59 @@
               </a:lnSpc>
             </a:pPr>
             <a:r>
-              <a:rPr sz="4600" b="0" i="0">
+              <a:rPr sz="5400" b="0" i="0">
                 <a:solidFill>
                   <a:srgbClr val="F4C563"/>
                 </a:solidFill>
                 <a:latin typeface="Arial Black"/>
               </a:rPr>
-              <a:t>ACBF</a:t>
-            </a:r>
-          </a:p>
+              <a:t>Comicaa</a:t>
+            </a:r>
+          </a:p>
+        </p:txBody>
+      </p:sp>
+      <p:sp>
+        <p:nvSpPr>
+          <p:cNvPr id="7" name="TextBox 6"/>
+          <p:cNvSpPr txBox="1"/>
+          <p:nvPr/>
+        </p:nvSpPr>
+        <p:spPr>
+          <a:xfrm>
+            <a:off x="685800" y="1874519"/>
+            <a:ext cx="6400800" cy="457200"/>
+          </a:xfrm>
+          <a:prstGeom prst="rect">
+            <a:avLst/>
+          </a:prstGeom>
+          <a:noFill/>
+        </p:spPr>
+        <p:txBody>
+          <a:bodyPr wrap="square" anchor="t" lIns="0" rIns="0" tIns="0" bIns="0">
+            <a:spAutoFit/>
+          </a:bodyPr>
+          <a:lstStyle/>
           <a:p>
             <a:pPr algn="l">
               <a:lnSpc>
-                <a:spcPct val="100000"/>
+                <a:spcPct val="120000"/>
               </a:lnSpc>
             </a:pPr>
             <a:r>
-              <a:rPr sz="4600" b="0" i="0">
-                <a:solidFill>
-                  <a:srgbClr val="F4C563"/>
-                </a:solidFill>
-                <a:latin typeface="Arial Black"/>
+              <a:rPr sz="1800" b="0" i="0" spc="140">
+                <a:solidFill>
+                  <a:srgbClr val="6FB7D9"/>
+                </a:solidFill>
+                <a:latin typeface="Consolas"/>
               </a:rPr>
-              <a:t>PANEL EDITOR</a:t>
-            </a:r>
-          </a:p>
-        </p:txBody>
-      </p:sp>
-      <p:sp>
-        <p:nvSpPr>
-          <p:cNvPr id="7" name="TextBox 6"/>
+              <a:t>ACBF PANEL EDITOR</a:t>
+            </a:r>
+          </a:p>
+        </p:txBody>
+      </p:sp>
+      <p:sp>
+        <p:nvSpPr>
+          <p:cNvPr id="8" name="TextBox 7"/>
           <p:cNvSpPr txBox="1"/>
           <p:nvPr/>
         </p:nvSpPr>
@@ -3382,7 +3405,7 @@
       </p:sp>
       <p:sp>
         <p:nvSpPr>
-          <p:cNvPr id="8" name="Rounded Rectangle 7"/>
+          <p:cNvPr id="9" name="Rounded Rectangle 8"/>
           <p:cNvSpPr/>
           <p:nvPr/>
         </p:nvSpPr>
@@ -3428,7 +3451,7 @@
       </p:sp>
       <p:sp>
         <p:nvSpPr>
-          <p:cNvPr id="9" name="TextBox 8"/>
+          <p:cNvPr id="10" name="TextBox 9"/>
           <p:cNvSpPr txBox="1"/>
           <p:nvPr/>
         </p:nvSpPr>
@@ -3467,7 +3490,7 @@
       </p:sp>
       <p:sp>
         <p:nvSpPr>
-          <p:cNvPr id="10" name="TextBox 9"/>
+          <p:cNvPr id="11" name="TextBox 10"/>
           <p:cNvSpPr txBox="1"/>
           <p:nvPr/>
         </p:nvSpPr>
@@ -3506,7 +3529,7 @@
       </p:sp>
       <p:sp>
         <p:nvSpPr>
-          <p:cNvPr id="11" name="Rounded Rectangle 10"/>
+          <p:cNvPr id="12" name="Rounded Rectangle 11"/>
           <p:cNvSpPr/>
           <p:nvPr/>
         </p:nvSpPr>
@@ -3552,7 +3575,7 @@
       </p:sp>
       <p:sp>
         <p:nvSpPr>
-          <p:cNvPr id="12" name="TextBox 11"/>
+          <p:cNvPr id="13" name="TextBox 12"/>
           <p:cNvSpPr txBox="1"/>
           <p:nvPr/>
         </p:nvSpPr>
@@ -3591,7 +3614,7 @@
       </p:sp>
       <p:sp>
         <p:nvSpPr>
-          <p:cNvPr id="13" name="TextBox 12"/>
+          <p:cNvPr id="14" name="TextBox 13"/>
           <p:cNvSpPr txBox="1"/>
           <p:nvPr/>
         </p:nvSpPr>
@@ -3630,7 +3653,7 @@
       </p:sp>
       <p:sp>
         <p:nvSpPr>
-          <p:cNvPr id="14" name="Rounded Rectangle 13"/>
+          <p:cNvPr id="15" name="Rounded Rectangle 14"/>
           <p:cNvSpPr/>
           <p:nvPr/>
         </p:nvSpPr>
@@ -3676,7 +3699,7 @@
       </p:sp>
       <p:sp>
         <p:nvSpPr>
-          <p:cNvPr id="15" name="TextBox 14"/>
+          <p:cNvPr id="16" name="TextBox 15"/>
           <p:cNvSpPr txBox="1"/>
           <p:nvPr/>
         </p:nvSpPr>
@@ -5546,8 +5569,8 @@
         </p:blipFill>
         <p:spPr>
           <a:xfrm>
-            <a:off x="4802428" y="2258568"/>
-            <a:ext cx="6305702" cy="3941063"/>
+            <a:off x="4544568" y="2395842"/>
+            <a:ext cx="6821424" cy="3666515"/>
           </a:xfrm>
           <a:prstGeom prst="rect">
             <a:avLst/>
@@ -6254,8 +6277,8 @@
         </p:blipFill>
         <p:spPr>
           <a:xfrm>
-            <a:off x="4802428" y="2258568"/>
-            <a:ext cx="6305702" cy="3941063"/>
+            <a:off x="4544568" y="2395842"/>
+            <a:ext cx="6821424" cy="3666515"/>
           </a:xfrm>
           <a:prstGeom prst="rect">
             <a:avLst/>
@@ -6962,8 +6985,8 @@
         </p:blipFill>
         <p:spPr>
           <a:xfrm>
-            <a:off x="4802428" y="2258568"/>
-            <a:ext cx="6305702" cy="3941063"/>
+            <a:off x="4544568" y="2395842"/>
+            <a:ext cx="6821424" cy="3666515"/>
           </a:xfrm>
           <a:prstGeom prst="rect">
             <a:avLst/>

</xml_diff>